<commit_message>
Slide: didascalie piu' precise e soglia con media dei 5 seed
- Pulizia: 2.843 righe rimosse e 2.143 etichette corrette, senza somma
- Grafico famiglie: conteggi prima della pulizia, lunghezza in scala log
- Istogramma: validation, un autoencoder
- Soglia regolabile: recall e falsi allarmi come media dei 5 seed
</commit_message>
<xml_diff>
--- a/slides/presentazione_design_origin_v2.pptx
+++ b/slides/presentazione_design_origin_v2.pptx
@@ -3783,7 +3783,7 @@
         <p:spPr>
           <a:xfrm>
             <a:off x="1234440" y="3291840"/>
-            <a:ext cx="5486400" cy="237744"/>
+            <a:ext cx="9692640" cy="237744"/>
           </a:xfrm>
           <a:prstGeom prst="rect">
             <a:avLst/>
@@ -3807,7 +3807,7 @@
                 <a:ea typeface="Segoe UI Semibold" pitchFamily="34" charset="-122"/>
                 <a:cs typeface="Segoe UI Semibold" pitchFamily="34" charset="-120"/>
               </a:rPr>
-              <a:t>FLUSSI PER FAMIGLIA · SCALA LOGARITMICA</a:t>
+              <a:t>FLUSSI PER FAMIGLIA, PRIMA DELLA PULIZIA · LUNGHEZZA IN SCALA LOG</a:t>
             </a:r>
             <a:endParaRPr lang="en-US" sz="1050" dirty="0"/>
           </a:p>
@@ -4002,7 +4002,7 @@
                 <a:ea typeface="Georgia" pitchFamily="34" charset="-122"/>
                 <a:cs typeface="Georgia" pitchFamily="34" charset="-120"/>
               </a:rPr>
-              <a:t>2.143 + 2.843</a:t>
+              <a:t>2.843</a:t>
             </a:r>
             <a:endParaRPr lang="en-US" sz="3400" dirty="0"/>
           </a:p>
@@ -4041,7 +4041,7 @@
                 <a:ea typeface="Segoe UI" pitchFamily="34" charset="-122"/>
                 <a:cs typeface="Segoe UI" pitchFamily="34" charset="-120"/>
               </a:rPr>
-              <a:t>etichette corrette + righe rimosse</a:t>
+              <a:t>righe rimosse · 2.143 etichette corrette</a:t>
             </a:r>
             <a:endParaRPr lang="en-US" sz="1200" dirty="0"/>
           </a:p>
@@ -9948,7 +9948,7 @@
                 <a:ea typeface="Segoe UI Semibold" pitchFamily="34" charset="-122"/>
                 <a:cs typeface="Segoe UI Semibold" pitchFamily="34" charset="-120"/>
               </a:rPr>
-              <a:t>ERRORE DI RICOSTRUZIONE · AUTOENCODER SOLO SU BENIGN</a:t>
+              <a:t>ERRORE DI RICOSTRUZIONE (VALIDATION, UN AUTOENCODER)</a:t>
             </a:r>
             <a:endParaRPr lang="en-US" sz="1050" dirty="0"/>
           </a:p>
@@ -14445,7 +14445,7 @@
                 </a:solidFill>
                 <a:latin typeface="Segoe UI Semibold"/>
               </a:rPr>
-              <a:t>SOGLIA REGOLABILE · TEST SET</a:t>
+              <a:t>SOGLIA REGOLABILE · TEST SET, MEDIA DI 5 SEED</a:t>
             </a:r>
           </a:p>
         </p:txBody>
@@ -14494,7 +14494,7 @@
         <p:spPr>
           <a:xfrm>
             <a:off x="1874520" y="5084064"/>
-            <a:ext cx="2049170" cy="128016"/>
+            <a:ext cx="2032711" cy="128016"/>
           </a:xfrm>
           <a:prstGeom prst="rect">
             <a:avLst/>
@@ -14535,7 +14535,7 @@
         </p:nvSpPr>
         <p:spPr>
           <a:xfrm>
-            <a:off x="3996842" y="5047488"/>
+            <a:off x="3980383" y="5047488"/>
             <a:ext cx="1828800" cy="201168"/>
           </a:xfrm>
           <a:prstGeom prst="rect">
@@ -14557,7 +14557,7 @@
                 </a:solidFill>
                 <a:latin typeface="Segoe UI"/>
               </a:rPr>
-              <a:t>74,7% dei DoS riconosciuti</a:t>
+              <a:t>74,1% dei DoS riconosciuti</a:t>
             </a:r>
           </a:p>
         </p:txBody>
@@ -14606,7 +14606,7 @@
         <p:spPr>
           <a:xfrm>
             <a:off x="1874520" y="5312664"/>
-            <a:ext cx="1300277" cy="128016"/>
+            <a:ext cx="1207008" cy="128016"/>
           </a:xfrm>
           <a:prstGeom prst="rect">
             <a:avLst/>
@@ -14647,7 +14647,7 @@
         </p:nvSpPr>
         <p:spPr>
           <a:xfrm>
-            <a:off x="3247949" y="5276088"/>
+            <a:off x="3154680" y="5276088"/>
             <a:ext cx="1828800" cy="201168"/>
           </a:xfrm>
           <a:prstGeom prst="rect">
@@ -14669,7 +14669,7 @@
                 </a:solidFill>
                 <a:latin typeface="Segoe UI"/>
               </a:rPr>
-              <a:t>47,4% dei DoS riconosciuti</a:t>
+              <a:t>44,0% dei DoS riconosciuti</a:t>
             </a:r>
           </a:p>
         </p:txBody>
@@ -14781,7 +14781,7 @@
                 </a:solidFill>
                 <a:latin typeface="Segoe UI"/>
               </a:rPr>
-              <a:t>3.944 falsi allarmi extra</a:t>
+              <a:t>0,99% di falsi allarmi extra</a:t>
             </a:r>
           </a:p>
         </p:txBody>
@@ -14830,7 +14830,7 @@
         <p:spPr>
           <a:xfrm>
             <a:off x="7013448" y="5312664"/>
-            <a:ext cx="218677" cy="128016"/>
+            <a:ext cx="221672" cy="128016"/>
           </a:xfrm>
           <a:prstGeom prst="rect">
             <a:avLst/>
@@ -14871,7 +14871,7 @@
         </p:nvSpPr>
         <p:spPr>
           <a:xfrm>
-            <a:off x="7305277" y="5276088"/>
+            <a:off x="7308272" y="5276088"/>
             <a:ext cx="1828800" cy="201168"/>
           </a:xfrm>
           <a:prstGeom prst="rect">
@@ -14893,7 +14893,7 @@
                 </a:solidFill>
                 <a:latin typeface="Segoe UI"/>
               </a:rPr>
-              <a:t>393 falsi allarmi extra</a:t>
+              <a:t>0,10% di falsi allarmi extra</a:t>
             </a:r>
           </a:p>
         </p:txBody>

</xml_diff>

<commit_message>
Slide 6: soglia con i numeri della run principale, come la slide 5
74,7% / 47,4% e 3.944 / 393 falsi allarmi (cella 66), coerenti con
18,1% -> 74,7% e 3.944 della slide 5.
</commit_message>
<xml_diff>
--- a/slides/presentazione_design_origin_v2.pptx
+++ b/slides/presentazione_design_origin_v2.pptx
@@ -14445,7 +14445,7 @@
                 </a:solidFill>
                 <a:latin typeface="Segoe UI Semibold"/>
               </a:rPr>
-              <a:t>SOGLIA REGOLABILE · TEST SET, MEDIA DI 5 SEED</a:t>
+              <a:t>SOGLIA REGOLABILE · TEST SET</a:t>
             </a:r>
           </a:p>
         </p:txBody>
@@ -14494,7 +14494,7 @@
         <p:spPr>
           <a:xfrm>
             <a:off x="1874520" y="5084064"/>
-            <a:ext cx="2032711" cy="128016"/>
+            <a:ext cx="2049170" cy="128016"/>
           </a:xfrm>
           <a:prstGeom prst="rect">
             <a:avLst/>
@@ -14535,7 +14535,7 @@
         </p:nvSpPr>
         <p:spPr>
           <a:xfrm>
-            <a:off x="3980383" y="5047488"/>
+            <a:off x="3996842" y="5047488"/>
             <a:ext cx="1828800" cy="201168"/>
           </a:xfrm>
           <a:prstGeom prst="rect">
@@ -14557,7 +14557,7 @@
                 </a:solidFill>
                 <a:latin typeface="Segoe UI"/>
               </a:rPr>
-              <a:t>74,1% dei DoS riconosciuti</a:t>
+              <a:t>74,7% dei DoS riconosciuti</a:t>
             </a:r>
           </a:p>
         </p:txBody>
@@ -14606,7 +14606,7 @@
         <p:spPr>
           <a:xfrm>
             <a:off x="1874520" y="5312664"/>
-            <a:ext cx="1207008" cy="128016"/>
+            <a:ext cx="1300276" cy="128016"/>
           </a:xfrm>
           <a:prstGeom prst="rect">
             <a:avLst/>
@@ -14647,7 +14647,7 @@
         </p:nvSpPr>
         <p:spPr>
           <a:xfrm>
-            <a:off x="3154680" y="5276088"/>
+            <a:off x="3247948" y="5276088"/>
             <a:ext cx="1828800" cy="201168"/>
           </a:xfrm>
           <a:prstGeom prst="rect">
@@ -14669,7 +14669,7 @@
                 </a:solidFill>
                 <a:latin typeface="Segoe UI"/>
               </a:rPr>
-              <a:t>44,0% dei DoS riconosciuti</a:t>
+              <a:t>47,4% dei DoS riconosciuti</a:t>
             </a:r>
           </a:p>
         </p:txBody>
@@ -14781,7 +14781,7 @@
                 </a:solidFill>
                 <a:latin typeface="Segoe UI"/>
               </a:rPr>
-              <a:t>0,99% di falsi allarmi extra</a:t>
+              <a:t>3.944 falsi allarmi extra</a:t>
             </a:r>
           </a:p>
         </p:txBody>
@@ -14830,7 +14830,7 @@
         <p:spPr>
           <a:xfrm>
             <a:off x="7013448" y="5312664"/>
-            <a:ext cx="221672" cy="128016"/>
+            <a:ext cx="218676" cy="128016"/>
           </a:xfrm>
           <a:prstGeom prst="rect">
             <a:avLst/>
@@ -14871,7 +14871,7 @@
         </p:nvSpPr>
         <p:spPr>
           <a:xfrm>
-            <a:off x="7308272" y="5276088"/>
+            <a:off x="7305276" y="5276088"/>
             <a:ext cx="1828800" cy="201168"/>
           </a:xfrm>
           <a:prstGeom prst="rect">
@@ -14893,7 +14893,7 @@
                 </a:solidFill>
                 <a:latin typeface="Segoe UI"/>
               </a:rPr>
-              <a:t>0,10% di falsi allarmi extra</a:t>
+              <a:t>393 falsi allarmi extra</a:t>
             </a:r>
           </a:p>
         </p:txBody>

</xml_diff>

<commit_message>
Slide 8: 'Grazie per l'attenzione' al posto di 'Grazie — domande?'
</commit_message>
<xml_diff>
--- a/slides/presentazione_design_origin_v2.pptx
+++ b/slides/presentazione_design_origin_v2.pptx
@@ -16496,6 +16496,10 @@
             <a:prstDash val="solid"/>
           </a:ln>
         </p:spPr>
+        <p:txBody>
+          <a:bodyPr/>
+          <a:p/>
+        </p:txBody>
       </p:sp>
       <p:pic>
         <p:nvPicPr>
@@ -16733,6 +16737,10 @@
             <a:prstDash val="solid"/>
           </a:ln>
         </p:spPr>
+        <p:txBody>
+          <a:bodyPr/>
+          <a:p/>
+        </p:txBody>
       </p:sp>
       <p:sp>
         <p:nvSpPr>
@@ -16820,6 +16828,10 @@
             <a:prstDash val="solid"/>
           </a:ln>
         </p:spPr>
+        <p:txBody>
+          <a:bodyPr/>
+          <a:p/>
+        </p:txBody>
       </p:sp>
       <p:sp>
         <p:nvSpPr>
@@ -17052,7 +17064,7 @@
                 <a:ea typeface="Segoe UI Semibold" pitchFamily="34" charset="-122"/>
                 <a:cs typeface="Segoe UI Semibold" pitchFamily="34" charset="-120"/>
               </a:rPr>
-              <a:t>Grazie — domande? →</a:t>
+              <a:t>Grazie per l'attenzione</a:t>
             </a:r>
             <a:endParaRPr lang="en-US" sz="1300" dirty="0"/>
           </a:p>

</xml_diff>